<commit_message>
viz: correccion — NB01 exploratorio puro + NB02 aclaratorio con 5 preguntas de negocio
</commit_message>
<xml_diff>
--- a/visualizacion_datos/entregables/deslizamientos_ml.pptx
+++ b/visualizacion_datos/entregables/deslizamientos_ml.pptx
@@ -5726,7 +5726,7 @@
                 <a:ea typeface="Calibri" pitchFamily="34" charset="-122"/>
                 <a:cs typeface="Calibri" pitchFamily="34" charset="-120"/>
               </a:rPr>
-              <a:t>¿Qué información satelital necesita Colombia?</a:t>
+              <a:t>¿Qué canales satelitales discriminan más — y puede acceder Colombia a ellos?</a:t>
             </a:r>
             <a:endParaRPr lang="en-US" sz="2000" dirty="0"/>
           </a:p>
@@ -5762,7 +5762,7 @@
                   <a:srgbClr val="64748B"/>
                 </a:solidFill>
               </a:rPr>
-              <a:t>Las bandas RedEdge (Sentinel-2) son las más discriminativas y están disponibles en Copernicus</a:t>
+              <a:t>RedEdge separa las clases con una brecha 4× mayor que SAR-VH · Las bandas de mayor poder discriminativo son gratuitas en Copernicus</a:t>
             </a:r>
             <a:endParaRPr lang="en-US" sz="1100" dirty="0"/>
           </a:p>
@@ -5770,7 +5770,7 @@
       </p:sp>
       <p:pic>
         <p:nvPicPr>
-          <p:cNvPr id="4" name="Image 0" descr="/sessions/fervent-charming-galileo/mnt/Landslide_ML/visualizacion_datos/data/figures/comp_a4_canales_colombia.png">    </p:cNvPr>
+          <p:cNvPr id="4" name="Image 0" descr="/sessions/fervent-charming-galileo/mnt/Landslide_ML/visualizacion_datos/data/figures/comp_a4_canales_fusion.png">    </p:cNvPr>
           <p:cNvPicPr>
             <a:picLocks noChangeAspect="1"/>
           </p:cNvPicPr>

</xml_diff>